<commit_message>
Adjust slide three wording after user review
</commit_message>
<xml_diff>
--- a/hackathon/output/final/team3_project.pptx
+++ b/hackathon/output/final/team3_project.pptx
@@ -15331,7 +15331,7 @@
       </p:sp>
       <p:sp>
         <p:nvSpPr>
-          <p:cNvPr id="67" name="Автоматически проверяем действие.">
+          <p:cNvPr id="67" name="Запросы настолько безопасны,">
             <a:extLst xmlns:a="http://schemas.openxmlformats.org/drawingml/2006/main">
               <a:ext uri="{FF2B5EF4-FFF2-40B4-BE49-F238E27FC236}">
                 <a16:creationId xmlns:a16="http://schemas.microsoft.com/office/drawing/2014/main" id="{1A2474F8-78F9-4441-8D30-C0BFFFF99EF4}"/>
@@ -15381,7 +15381,7 @@
                 <a:ea typeface="Inter"/>
                 <a:cs typeface="Inter"/>
               </a:rPr>
-              <a:t>Автоматически проверяем действие.</a:t>
+              <a:t>Запросы настолько безопасны,</a:t>
             </a:r>
           </a:p>
           <a:p xmlns:a="http://schemas.openxmlformats.org/drawingml/2006/main">
@@ -15404,7 +15404,7 @@
                 <a:ea typeface="Inter"/>
                 <a:cs typeface="Inter"/>
               </a:rPr>
-              <a:t>При риске сохраняем возможность отказа и уточнения.</a:t>
+              <a:t>что стало опасно.</a:t>
             </a:r>
           </a:p>
         </p:txBody>

</xml_diff>